<commit_message>
Update EuroTcl 2026 slides (PPTX + PDF)
Now 24 slides: adds borg command, an AltStore install walkthrough, and iOS 9
+ de1app screenshots; reorders the App-Review and case-study slides; drops the
lessons slide.

Co-Authored-By: Claude Opus 4.8 <noreply@anthropic.com>
</commit_message>
<xml_diff>
--- a/iWish-for-iOS.pptx
+++ b/iWish-for-iOS.pptx
@@ -28,9 +28,10 @@
     <p:sldId id="276" r:id="rId22"/>
     <p:sldId id="277" r:id="rId23"/>
     <p:sldId id="278" r:id="rId24"/>
+    <p:sldId id="279" r:id="rId25"/>
   </p:sldIdLst>
   <p:notesMasterIdLst>
-    <p:notesMasterId r:id="rId25"/>
+    <p:notesMasterId r:id="rId26"/>
   </p:notesMasterIdLst>
   <p:sldSz cx="9144000" cy="5143500"/>
   <p:notesSz cx="5143500" cy="9144000"/>
@@ -1868,6 +1869,94 @@
             <a:fld id="{F7021451-1387-4CA6-816F-3879F97B5CBC}" type="slidenum">
               <a:rPr lang="en-US"/>
               <a:t>23</a:t>
+            </a:fld>
+            <a:endParaRPr lang="en-US"/>
+          </a:p>
+        </p:txBody>
+      </p:sp>
+    </p:spTree>
+    <p:extLst>
+      <p:ext uri="{BB962C8B-B14F-4D97-AF65-F5344CB8AC3E}">
+        <p14:creationId xmlns:p14="http://schemas.microsoft.com/office/powerpoint/2010/main" val="1024086991"/>
+      </p:ext>
+    </p:extLst>
+  </p:cSld>
+  <p:clrMapOvr>
+    <a:masterClrMapping/>
+  </p:clrMapOvr>
+</p:notes>
+</file>
+
+<file path=ppt/notesSlides/notesSlide24.xml><?xml version="1.0" encoding="utf-8"?>
+<p:notes xmlns:a="http://schemas.openxmlformats.org/drawingml/2006/main" xmlns:r="http://schemas.openxmlformats.org/officeDocument/2006/relationships" xmlns:p="http://schemas.openxmlformats.org/presentationml/2006/main">
+  <p:cSld>
+    <p:spTree>
+      <p:nvGrpSpPr>
+        <p:cNvPr id="1" name=""/>
+        <p:cNvGrpSpPr/>
+        <p:nvPr/>
+      </p:nvGrpSpPr>
+      <p:grpSpPr>
+        <a:xfrm>
+          <a:off x="0" y="0"/>
+          <a:ext cx="0" cy="0"/>
+          <a:chOff x="0" y="0"/>
+          <a:chExt cx="0" cy="0"/>
+        </a:xfrm>
+      </p:grpSpPr>
+      <p:sp>
+        <p:nvSpPr>
+          <p:cNvPr id="2" name="Slide Image Placeholder 1"/>
+          <p:cNvSpPr>
+            <a:spLocks noGrp="1" noRot="1" noChangeAspect="1"/>
+          </p:cNvSpPr>
+          <p:nvPr>
+            <p:ph type="sldImg"/>
+          </p:nvPr>
+        </p:nvSpPr>
+        <p:spPr/>
+      </p:sp>
+      <p:sp>
+        <p:nvSpPr>
+          <p:cNvPr id="3" name="Notes Placeholder 2"/>
+          <p:cNvSpPr>
+            <a:spLocks noGrp="1"/>
+          </p:cNvSpPr>
+          <p:nvPr>
+            <p:ph type="body" idx="1"/>
+          </p:nvPr>
+        </p:nvSpPr>
+        <p:spPr/>
+        <p:txBody>
+          <a:bodyPr/>
+          <a:lstStyle/>
+          <a:p>
+            <a:r>
+              <a:rPr lang="en-US" dirty="0"/>
+              <a:t/>
+            </a:r>
+            <a:endParaRPr lang="en-US" dirty="0"/>
+          </a:p>
+        </p:txBody>
+      </p:sp>
+      <p:sp>
+        <p:nvSpPr>
+          <p:cNvPr id="4" name="Slide Number Placeholder 3"/>
+          <p:cNvSpPr>
+            <a:spLocks noGrp="1"/>
+          </p:cNvSpPr>
+          <p:nvPr>
+            <p:ph type="sldNum" sz="quarter" idx="10"/>
+          </p:nvPr>
+        </p:nvSpPr>
+        <p:spPr/>
+        <p:txBody>
+          <a:bodyPr/>
+          <a:lstStyle/>
+          <a:p>
+            <a:fld id="{F7021451-1387-4CA6-816F-3879F97B5CBC}" type="slidenum">
+              <a:rPr lang="en-US"/>
+              <a:t>24</a:t>
             </a:fld>
             <a:endParaRPr lang="en-US"/>
           </a:p>
@@ -12516,7 +12605,7 @@
                 <a:ea typeface="Calibri" pitchFamily="34" charset="-122"/>
                 <a:cs typeface="Calibri" pitchFamily="34" charset="-120"/>
               </a:rPr>
-              <a:t>CALL FOR COLLABORATORS</a:t>
+              <a:t>METHOD · ALTSTORE</a:t>
             </a:r>
             <a:endParaRPr lang="en-US" sz="1200" dirty="0"/>
           </a:p>
@@ -12558,7 +12647,7 @@
                 <a:ea typeface="Cambria" pitchFamily="34" charset="-122"/>
                 <a:cs typeface="Cambria" pitchFamily="34" charset="-120"/>
               </a:rPr>
-              <a:t>Wanted: an EU Company (or Org) to help distribute a free Tcl/Tk without limitations</a:t>
+              <a:t>AltStore: installing de1app step by step</a:t>
             </a:r>
             <a:endParaRPr lang="en-US" sz="3000" dirty="0"/>
           </a:p>
@@ -12566,145 +12655,823 @@
       </p:sp>
       <p:sp>
         <p:nvSpPr>
-          <p:cNvPr id="4" name="Text 2"/>
-          <p:cNvSpPr/>
-          <p:nvPr/>
-        </p:nvSpPr>
-        <p:spPr>
-          <a:xfrm>
-            <a:off x="502920" y="1965960"/>
-            <a:ext cx="5029200" cy="2377440"/>
-          </a:xfrm>
-          <a:prstGeom prst="rect">
-            <a:avLst/>
-          </a:prstGeom>
-          <a:noFill/>
-          <a:ln/>
-        </p:spPr>
-        <p:txBody>
-          <a:bodyPr wrap="square" lIns="0" tIns="0" rIns="0" bIns="0" rtlCol="0" anchor="t"/>
-          <a:lstStyle/>
-          <a:p>
-            <a:pPr algn="l" marL="203200" indent="-203200">
-              <a:spcAft>
-                <a:spcPts val="800"/>
-              </a:spcAft>
-              <a:buSzPct val="100000"/>
-              <a:buChar char="•"/>
-            </a:pPr>
-            <a:r>
-              <a:rPr lang="en-US" sz="1400" b="1" dirty="0">
-                <a:solidFill>
-                  <a:srgbClr val="ECEFF4"/>
-                </a:solidFill>
-                <a:latin typeface="Calibri" pitchFamily="34" charset="0"/>
-                <a:ea typeface="Calibri" pitchFamily="34" charset="-122"/>
-                <a:cs typeface="Calibri" pitchFamily="34" charset="-120"/>
-              </a:rPr>
-              <a:t>I'm looking for a partner with an EU-registered company</a:t>
-            </a:r>
-            <a:endParaRPr lang="en-US" sz="1400" dirty="0"/>
-          </a:p>
-          <a:p>
-            <a:pPr algn="l" marL="203200" indent="-203200">
-              <a:spcAft>
-                <a:spcPts val="800"/>
-              </a:spcAft>
-              <a:buSzPct val="100000"/>
-              <a:buChar char="•"/>
-            </a:pPr>
-            <a:r>
-              <a:rPr lang="en-US" sz="1400" dirty="0">
-                <a:solidFill>
-                  <a:srgbClr val="ECEFF4"/>
-                </a:solidFill>
-                <a:latin typeface="Calibri" pitchFamily="34" charset="0"/>
-                <a:ea typeface="Calibri" pitchFamily="34" charset="-122"/>
-                <a:cs typeface="Calibri" pitchFamily="34" charset="-120"/>
-              </a:rPr>
-              <a:t>…willing to sign Apple's distribution paperwork</a:t>
-            </a:r>
-            <a:endParaRPr lang="en-US" sz="1400" dirty="0"/>
-          </a:p>
-          <a:p>
-            <a:pPr algn="l" marL="203200" indent="-203200">
-              <a:spcAft>
-                <a:spcPts val="800"/>
-              </a:spcAft>
-              <a:buSzPct val="100000"/>
-              <a:buChar char="•"/>
-            </a:pPr>
-            <a:r>
-              <a:rPr lang="en-US" sz="1400" dirty="0">
-                <a:solidFill>
-                  <a:srgbClr val="ECEFF4"/>
-                </a:solidFill>
-                <a:latin typeface="Calibri" pitchFamily="34" charset="0"/>
-                <a:ea typeface="Calibri" pitchFamily="34" charset="-122"/>
-                <a:cs typeface="Calibri" pitchFamily="34" charset="-120"/>
-              </a:rPr>
-              <a:t>Then we ship a notarized IPA for open sideloading</a:t>
-            </a:r>
-            <a:endParaRPr lang="en-US" sz="1400" dirty="0"/>
-          </a:p>
-          <a:p>
-            <a:pPr algn="l" marL="203200" indent="-203200">
-              <a:spcAft>
-                <a:spcPts val="800"/>
-              </a:spcAft>
-              <a:buSzPct val="100000"/>
-              <a:buChar char="•"/>
-            </a:pPr>
-            <a:r>
-              <a:rPr lang="en-US" sz="1400" dirty="0">
-                <a:solidFill>
-                  <a:srgbClr val="ECEFF4"/>
-                </a:solidFill>
-                <a:latin typeface="Calibri" pitchFamily="34" charset="0"/>
-                <a:ea typeface="Calibri" pitchFamily="34" charset="-122"/>
-                <a:cs typeface="Calibri" pitchFamily="34" charset="-120"/>
-              </a:rPr>
-              <a:t>Europeans get iWish + the DE1 app — no 7-day expiry, no device cap</a:t>
-            </a:r>
-            <a:endParaRPr lang="en-US" sz="1400" dirty="0"/>
-          </a:p>
-          <a:p>
-            <a:pPr algn="l" marL="203200" indent="-203200">
-              <a:spcAft>
-                <a:spcPts val="800"/>
-              </a:spcAft>
-              <a:buSzPct val="100000"/>
-              <a:buChar char="•"/>
-            </a:pPr>
-            <a:r>
-              <a:rPr lang="en-US" sz="1400" dirty="0">
-                <a:solidFill>
-                  <a:srgbClr val="ECEFF4"/>
-                </a:solidFill>
-                <a:latin typeface="Calibri" pitchFamily="34" charset="0"/>
-                <a:ea typeface="Calibri" pitchFamily="34" charset="-122"/>
-                <a:cs typeface="Calibri" pitchFamily="34" charset="-120"/>
-              </a:rPr>
-              <a:t>You're the EU entity of record; I bring the app and the work</a:t>
-            </a:r>
-            <a:endParaRPr lang="en-US" sz="1400" dirty="0"/>
-          </a:p>
-        </p:txBody>
-      </p:sp>
-      <p:sp>
-        <p:nvSpPr>
-          <p:cNvPr id="5" name="Shape 3"/>
-          <p:cNvSpPr/>
-          <p:nvPr/>
-        </p:nvSpPr>
-        <p:spPr>
-          <a:xfrm>
-            <a:off x="5806440" y="1965960"/>
-            <a:ext cx="2834640" cy="2331720"/>
+          <p:cNvPr id="4" name="Shape 2"/>
+          <p:cNvSpPr/>
+          <p:nvPr/>
+        </p:nvSpPr>
+        <p:spPr>
+          <a:xfrm>
+            <a:off x="1609344" y="1513332"/>
+            <a:ext cx="1133856" cy="1956816"/>
           </a:xfrm>
           <a:prstGeom prst="roundRect">
             <a:avLst>
-              <a:gd name="adj" fmla="val 3529"/>
+              <a:gd name="adj" fmla="val 4032"/>
+            </a:avLst>
+          </a:prstGeom>
+          <a:solidFill>
+            <a:srgbClr val="1E2632"/>
+          </a:solidFill>
+          <a:ln w="12700">
+            <a:solidFill>
+              <a:srgbClr val="2A3341"/>
+            </a:solidFill>
+            <a:prstDash val="solid"/>
+          </a:ln>
+          <a:effectLst>
+            <a:outerShdw sx="100000" sy="100000" kx="0" ky="0" algn="bl" rotWithShape="0" blurRad="88900" dist="25400" dir="5400000">
+              <a:srgbClr val="000000">
+                <a:alpha val="28000"/>
+              </a:srgbClr>
+            </a:outerShdw>
+          </a:effectLst>
+        </p:spPr>
+      </p:sp>
+      <p:pic>
+        <p:nvPicPr>
+          <p:cNvPr id="5" name="Image 0" descr="AltStore step 1: Add source">    </p:cNvPr>
+          <p:cNvPicPr>
+            <a:picLocks noChangeAspect="1"/>
+          </p:cNvPicPr>
+          <p:nvPr/>
+        </p:nvPicPr>
+        <p:blipFill>
+          <a:blip r:embed="rId1"/>
+          <a:stretch>
+            <a:fillRect/>
+          </a:stretch>
+        </p:blipFill>
+        <p:spPr>
+          <a:xfrm>
+            <a:off x="1650492" y="1554480"/>
+            <a:ext cx="1051560" cy="1874520"/>
+          </a:xfrm>
+          <a:prstGeom prst="rect">
+            <a:avLst/>
+          </a:prstGeom>
+        </p:spPr>
+      </p:pic>
+      <p:sp>
+        <p:nvSpPr>
+          <p:cNvPr id="6" name="Shape 3"/>
+          <p:cNvSpPr/>
+          <p:nvPr/>
+        </p:nvSpPr>
+        <p:spPr>
+          <a:xfrm>
+            <a:off x="1632204" y="1444752"/>
+            <a:ext cx="292608" cy="292608"/>
+          </a:xfrm>
+          <a:prstGeom prst="ellipse">
+            <a:avLst/>
+          </a:prstGeom>
+          <a:solidFill>
+            <a:srgbClr val="E8552D"/>
+          </a:solidFill>
+          <a:ln w="19050">
+            <a:solidFill>
+              <a:srgbClr val="000000"/>
+            </a:solidFill>
+            <a:prstDash val="solid"/>
+          </a:ln>
+        </p:spPr>
+      </p:sp>
+      <p:sp>
+        <p:nvSpPr>
+          <p:cNvPr id="7" name="Text 4"/>
+          <p:cNvSpPr/>
+          <p:nvPr/>
+        </p:nvSpPr>
+        <p:spPr>
+          <a:xfrm>
+            <a:off x="1632204" y="1444752"/>
+            <a:ext cx="292608" cy="292608"/>
+          </a:xfrm>
+          <a:prstGeom prst="rect">
+            <a:avLst/>
+          </a:prstGeom>
+          <a:noFill/>
+          <a:ln/>
+        </p:spPr>
+        <p:txBody>
+          <a:bodyPr wrap="square" lIns="0" tIns="0" rIns="0" bIns="0" rtlCol="0" anchor="ctr"/>
+          <a:lstStyle/>
+          <a:p>
+            <a:pPr algn="ctr" indent="0" marL="0">
+              <a:buNone/>
+            </a:pPr>
+            <a:r>
+              <a:rPr lang="en-US" sz="1200" b="1" dirty="0">
+                <a:solidFill>
+                  <a:srgbClr val="FFFFFF"/>
+                </a:solidFill>
+                <a:latin typeface="Cambria" pitchFamily="34" charset="0"/>
+                <a:ea typeface="Cambria" pitchFamily="34" charset="-122"/>
+                <a:cs typeface="Cambria" pitchFamily="34" charset="-120"/>
+              </a:rPr>
+              <a:t>1</a:t>
+            </a:r>
+            <a:endParaRPr lang="en-US" sz="1200" dirty="0"/>
+          </a:p>
+        </p:txBody>
+      </p:sp>
+      <p:sp>
+        <p:nvSpPr>
+          <p:cNvPr id="8" name="Text 5"/>
+          <p:cNvSpPr/>
+          <p:nvPr/>
+        </p:nvSpPr>
+        <p:spPr>
+          <a:xfrm>
+            <a:off x="1559052" y="3493008"/>
+            <a:ext cx="1234440" cy="256032"/>
+          </a:xfrm>
+          <a:prstGeom prst="rect">
+            <a:avLst/>
+          </a:prstGeom>
+          <a:noFill/>
+          <a:ln/>
+        </p:spPr>
+        <p:txBody>
+          <a:bodyPr wrap="square" lIns="0" tIns="0" rIns="0" bIns="0" rtlCol="0" anchor="t"/>
+          <a:lstStyle/>
+          <a:p>
+            <a:pPr algn="ctr" indent="0" marL="0">
+              <a:buNone/>
+            </a:pPr>
+            <a:r>
+              <a:rPr lang="en-US" sz="1000" dirty="0">
+                <a:solidFill>
+                  <a:srgbClr val="9AA6B5"/>
+                </a:solidFill>
+                <a:latin typeface="Calibri" pitchFamily="34" charset="0"/>
+                <a:ea typeface="Calibri" pitchFamily="34" charset="-122"/>
+                <a:cs typeface="Calibri" pitchFamily="34" charset="-120"/>
+              </a:rPr>
+              <a:t>Add source</a:t>
+            </a:r>
+            <a:endParaRPr lang="en-US" sz="1000" dirty="0"/>
+          </a:p>
+        </p:txBody>
+      </p:sp>
+      <p:sp>
+        <p:nvSpPr>
+          <p:cNvPr id="9" name="Shape 6"/>
+          <p:cNvSpPr/>
+          <p:nvPr/>
+        </p:nvSpPr>
+        <p:spPr>
+          <a:xfrm>
+            <a:off x="2807208" y="1513332"/>
+            <a:ext cx="1133856" cy="1956816"/>
+          </a:xfrm>
+          <a:prstGeom prst="roundRect">
+            <a:avLst>
+              <a:gd name="adj" fmla="val 4032"/>
+            </a:avLst>
+          </a:prstGeom>
+          <a:solidFill>
+            <a:srgbClr val="1E2632"/>
+          </a:solidFill>
+          <a:ln w="12700">
+            <a:solidFill>
+              <a:srgbClr val="2A3341"/>
+            </a:solidFill>
+            <a:prstDash val="solid"/>
+          </a:ln>
+          <a:effectLst>
+            <a:outerShdw sx="100000" sy="100000" kx="0" ky="0" algn="bl" rotWithShape="0" blurRad="88900" dist="25400" dir="5400000">
+              <a:srgbClr val="000000">
+                <a:alpha val="28000"/>
+              </a:srgbClr>
+            </a:outerShdw>
+          </a:effectLst>
+        </p:spPr>
+      </p:sp>
+      <p:pic>
+        <p:nvPicPr>
+          <p:cNvPr id="10" name="Image 1" descr="AltStore step 2: Open source">    </p:cNvPr>
+          <p:cNvPicPr>
+            <a:picLocks noChangeAspect="1"/>
+          </p:cNvPicPr>
+          <p:nvPr/>
+        </p:nvPicPr>
+        <p:blipFill>
+          <a:blip r:embed="rId2"/>
+          <a:stretch>
+            <a:fillRect/>
+          </a:stretch>
+        </p:blipFill>
+        <p:spPr>
+          <a:xfrm>
+            <a:off x="2848356" y="1554480"/>
+            <a:ext cx="1051560" cy="1874520"/>
+          </a:xfrm>
+          <a:prstGeom prst="rect">
+            <a:avLst/>
+          </a:prstGeom>
+        </p:spPr>
+      </p:pic>
+      <p:sp>
+        <p:nvSpPr>
+          <p:cNvPr id="11" name="Shape 7"/>
+          <p:cNvSpPr/>
+          <p:nvPr/>
+        </p:nvSpPr>
+        <p:spPr>
+          <a:xfrm>
+            <a:off x="2830068" y="1444752"/>
+            <a:ext cx="292608" cy="292608"/>
+          </a:xfrm>
+          <a:prstGeom prst="ellipse">
+            <a:avLst/>
+          </a:prstGeom>
+          <a:solidFill>
+            <a:srgbClr val="E8552D"/>
+          </a:solidFill>
+          <a:ln w="19050">
+            <a:solidFill>
+              <a:srgbClr val="000000"/>
+            </a:solidFill>
+            <a:prstDash val="solid"/>
+          </a:ln>
+        </p:spPr>
+      </p:sp>
+      <p:sp>
+        <p:nvSpPr>
+          <p:cNvPr id="12" name="Text 8"/>
+          <p:cNvSpPr/>
+          <p:nvPr/>
+        </p:nvSpPr>
+        <p:spPr>
+          <a:xfrm>
+            <a:off x="2830068" y="1444752"/>
+            <a:ext cx="292608" cy="292608"/>
+          </a:xfrm>
+          <a:prstGeom prst="rect">
+            <a:avLst/>
+          </a:prstGeom>
+          <a:noFill/>
+          <a:ln/>
+        </p:spPr>
+        <p:txBody>
+          <a:bodyPr wrap="square" lIns="0" tIns="0" rIns="0" bIns="0" rtlCol="0" anchor="ctr"/>
+          <a:lstStyle/>
+          <a:p>
+            <a:pPr algn="ctr" indent="0" marL="0">
+              <a:buNone/>
+            </a:pPr>
+            <a:r>
+              <a:rPr lang="en-US" sz="1200" b="1" dirty="0">
+                <a:solidFill>
+                  <a:srgbClr val="FFFFFF"/>
+                </a:solidFill>
+                <a:latin typeface="Cambria" pitchFamily="34" charset="0"/>
+                <a:ea typeface="Cambria" pitchFamily="34" charset="-122"/>
+                <a:cs typeface="Cambria" pitchFamily="34" charset="-120"/>
+              </a:rPr>
+              <a:t>2</a:t>
+            </a:r>
+            <a:endParaRPr lang="en-US" sz="1200" dirty="0"/>
+          </a:p>
+        </p:txBody>
+      </p:sp>
+      <p:sp>
+        <p:nvSpPr>
+          <p:cNvPr id="13" name="Text 9"/>
+          <p:cNvSpPr/>
+          <p:nvPr/>
+        </p:nvSpPr>
+        <p:spPr>
+          <a:xfrm>
+            <a:off x="2756916" y="3493008"/>
+            <a:ext cx="1234440" cy="256032"/>
+          </a:xfrm>
+          <a:prstGeom prst="rect">
+            <a:avLst/>
+          </a:prstGeom>
+          <a:noFill/>
+          <a:ln/>
+        </p:spPr>
+        <p:txBody>
+          <a:bodyPr wrap="square" lIns="0" tIns="0" rIns="0" bIns="0" rtlCol="0" anchor="t"/>
+          <a:lstStyle/>
+          <a:p>
+            <a:pPr algn="ctr" indent="0" marL="0">
+              <a:buNone/>
+            </a:pPr>
+            <a:r>
+              <a:rPr lang="en-US" sz="1000" dirty="0">
+                <a:solidFill>
+                  <a:srgbClr val="9AA6B5"/>
+                </a:solidFill>
+                <a:latin typeface="Calibri" pitchFamily="34" charset="0"/>
+                <a:ea typeface="Calibri" pitchFamily="34" charset="-122"/>
+                <a:cs typeface="Calibri" pitchFamily="34" charset="-120"/>
+              </a:rPr>
+              <a:t>Open source</a:t>
+            </a:r>
+            <a:endParaRPr lang="en-US" sz="1000" dirty="0"/>
+          </a:p>
+        </p:txBody>
+      </p:sp>
+      <p:sp>
+        <p:nvSpPr>
+          <p:cNvPr id="14" name="Shape 10"/>
+          <p:cNvSpPr/>
+          <p:nvPr/>
+        </p:nvSpPr>
+        <p:spPr>
+          <a:xfrm>
+            <a:off x="4005072" y="1513332"/>
+            <a:ext cx="1133856" cy="1956816"/>
+          </a:xfrm>
+          <a:prstGeom prst="roundRect">
+            <a:avLst>
+              <a:gd name="adj" fmla="val 4032"/>
+            </a:avLst>
+          </a:prstGeom>
+          <a:solidFill>
+            <a:srgbClr val="1E2632"/>
+          </a:solidFill>
+          <a:ln w="12700">
+            <a:solidFill>
+              <a:srgbClr val="2A3341"/>
+            </a:solidFill>
+            <a:prstDash val="solid"/>
+          </a:ln>
+          <a:effectLst>
+            <a:outerShdw sx="100000" sy="100000" kx="0" ky="0" algn="bl" rotWithShape="0" blurRad="88900" dist="25400" dir="5400000">
+              <a:srgbClr val="000000">
+                <a:alpha val="28000"/>
+              </a:srgbClr>
+            </a:outerShdw>
+          </a:effectLst>
+        </p:spPr>
+      </p:sp>
+      <p:pic>
+        <p:nvPicPr>
+          <p:cNvPr id="15" name="Image 2" descr="AltStore step 3: de1app page">    </p:cNvPr>
+          <p:cNvPicPr>
+            <a:picLocks noChangeAspect="1"/>
+          </p:cNvPicPr>
+          <p:nvPr/>
+        </p:nvPicPr>
+        <p:blipFill>
+          <a:blip r:embed="rId3"/>
+          <a:stretch>
+            <a:fillRect/>
+          </a:stretch>
+        </p:blipFill>
+        <p:spPr>
+          <a:xfrm>
+            <a:off x="4046220" y="1554480"/>
+            <a:ext cx="1051560" cy="1874520"/>
+          </a:xfrm>
+          <a:prstGeom prst="rect">
+            <a:avLst/>
+          </a:prstGeom>
+        </p:spPr>
+      </p:pic>
+      <p:sp>
+        <p:nvSpPr>
+          <p:cNvPr id="16" name="Shape 11"/>
+          <p:cNvSpPr/>
+          <p:nvPr/>
+        </p:nvSpPr>
+        <p:spPr>
+          <a:xfrm>
+            <a:off x="4027932" y="1444752"/>
+            <a:ext cx="292608" cy="292608"/>
+          </a:xfrm>
+          <a:prstGeom prst="ellipse">
+            <a:avLst/>
+          </a:prstGeom>
+          <a:solidFill>
+            <a:srgbClr val="E8552D"/>
+          </a:solidFill>
+          <a:ln w="19050">
+            <a:solidFill>
+              <a:srgbClr val="000000"/>
+            </a:solidFill>
+            <a:prstDash val="solid"/>
+          </a:ln>
+        </p:spPr>
+      </p:sp>
+      <p:sp>
+        <p:nvSpPr>
+          <p:cNvPr id="17" name="Text 12"/>
+          <p:cNvSpPr/>
+          <p:nvPr/>
+        </p:nvSpPr>
+        <p:spPr>
+          <a:xfrm>
+            <a:off x="4027932" y="1444752"/>
+            <a:ext cx="292608" cy="292608"/>
+          </a:xfrm>
+          <a:prstGeom prst="rect">
+            <a:avLst/>
+          </a:prstGeom>
+          <a:noFill/>
+          <a:ln/>
+        </p:spPr>
+        <p:txBody>
+          <a:bodyPr wrap="square" lIns="0" tIns="0" rIns="0" bIns="0" rtlCol="0" anchor="ctr"/>
+          <a:lstStyle/>
+          <a:p>
+            <a:pPr algn="ctr" indent="0" marL="0">
+              <a:buNone/>
+            </a:pPr>
+            <a:r>
+              <a:rPr lang="en-US" sz="1200" b="1" dirty="0">
+                <a:solidFill>
+                  <a:srgbClr val="FFFFFF"/>
+                </a:solidFill>
+                <a:latin typeface="Cambria" pitchFamily="34" charset="0"/>
+                <a:ea typeface="Cambria" pitchFamily="34" charset="-122"/>
+                <a:cs typeface="Cambria" pitchFamily="34" charset="-120"/>
+              </a:rPr>
+              <a:t>3</a:t>
+            </a:r>
+            <a:endParaRPr lang="en-US" sz="1200" dirty="0"/>
+          </a:p>
+        </p:txBody>
+      </p:sp>
+      <p:sp>
+        <p:nvSpPr>
+          <p:cNvPr id="18" name="Text 13"/>
+          <p:cNvSpPr/>
+          <p:nvPr/>
+        </p:nvSpPr>
+        <p:spPr>
+          <a:xfrm>
+            <a:off x="3954780" y="3493008"/>
+            <a:ext cx="1234440" cy="256032"/>
+          </a:xfrm>
+          <a:prstGeom prst="rect">
+            <a:avLst/>
+          </a:prstGeom>
+          <a:noFill/>
+          <a:ln/>
+        </p:spPr>
+        <p:txBody>
+          <a:bodyPr wrap="square" lIns="0" tIns="0" rIns="0" bIns="0" rtlCol="0" anchor="t"/>
+          <a:lstStyle/>
+          <a:p>
+            <a:pPr algn="ctr" indent="0" marL="0">
+              <a:buNone/>
+            </a:pPr>
+            <a:r>
+              <a:rPr lang="en-US" sz="1000" dirty="0">
+                <a:solidFill>
+                  <a:srgbClr val="9AA6B5"/>
+                </a:solidFill>
+                <a:latin typeface="Calibri" pitchFamily="34" charset="0"/>
+                <a:ea typeface="Calibri" pitchFamily="34" charset="-122"/>
+                <a:cs typeface="Calibri" pitchFamily="34" charset="-120"/>
+              </a:rPr>
+              <a:t>de1app page</a:t>
+            </a:r>
+            <a:endParaRPr lang="en-US" sz="1000" dirty="0"/>
+          </a:p>
+        </p:txBody>
+      </p:sp>
+      <p:sp>
+        <p:nvSpPr>
+          <p:cNvPr id="19" name="Shape 14"/>
+          <p:cNvSpPr/>
+          <p:nvPr/>
+        </p:nvSpPr>
+        <p:spPr>
+          <a:xfrm>
+            <a:off x="5202936" y="1513332"/>
+            <a:ext cx="1133856" cy="1956816"/>
+          </a:xfrm>
+          <a:prstGeom prst="roundRect">
+            <a:avLst>
+              <a:gd name="adj" fmla="val 4032"/>
+            </a:avLst>
+          </a:prstGeom>
+          <a:solidFill>
+            <a:srgbClr val="1E2632"/>
+          </a:solidFill>
+          <a:ln w="12700">
+            <a:solidFill>
+              <a:srgbClr val="2A3341"/>
+            </a:solidFill>
+            <a:prstDash val="solid"/>
+          </a:ln>
+          <a:effectLst>
+            <a:outerShdw sx="100000" sy="100000" kx="0" ky="0" algn="bl" rotWithShape="0" blurRad="88900" dist="25400" dir="5400000">
+              <a:srgbClr val="000000">
+                <a:alpha val="28000"/>
+              </a:srgbClr>
+            </a:outerShdw>
+          </a:effectLst>
+        </p:spPr>
+      </p:sp>
+      <p:pic>
+        <p:nvPicPr>
+          <p:cNvPr id="20" name="Image 3" descr="AltStore step 4: Sign in">    </p:cNvPr>
+          <p:cNvPicPr>
+            <a:picLocks noChangeAspect="1"/>
+          </p:cNvPicPr>
+          <p:nvPr/>
+        </p:nvPicPr>
+        <p:blipFill>
+          <a:blip r:embed="rId4"/>
+          <a:stretch>
+            <a:fillRect/>
+          </a:stretch>
+        </p:blipFill>
+        <p:spPr>
+          <a:xfrm>
+            <a:off x="5244084" y="1554480"/>
+            <a:ext cx="1051560" cy="1874520"/>
+          </a:xfrm>
+          <a:prstGeom prst="rect">
+            <a:avLst/>
+          </a:prstGeom>
+        </p:spPr>
+      </p:pic>
+      <p:sp>
+        <p:nvSpPr>
+          <p:cNvPr id="21" name="Shape 15"/>
+          <p:cNvSpPr/>
+          <p:nvPr/>
+        </p:nvSpPr>
+        <p:spPr>
+          <a:xfrm>
+            <a:off x="5225796" y="1444752"/>
+            <a:ext cx="292608" cy="292608"/>
+          </a:xfrm>
+          <a:prstGeom prst="ellipse">
+            <a:avLst/>
+          </a:prstGeom>
+          <a:solidFill>
+            <a:srgbClr val="E8552D"/>
+          </a:solidFill>
+          <a:ln w="19050">
+            <a:solidFill>
+              <a:srgbClr val="000000"/>
+            </a:solidFill>
+            <a:prstDash val="solid"/>
+          </a:ln>
+        </p:spPr>
+      </p:sp>
+      <p:sp>
+        <p:nvSpPr>
+          <p:cNvPr id="22" name="Text 16"/>
+          <p:cNvSpPr/>
+          <p:nvPr/>
+        </p:nvSpPr>
+        <p:spPr>
+          <a:xfrm>
+            <a:off x="5225796" y="1444752"/>
+            <a:ext cx="292608" cy="292608"/>
+          </a:xfrm>
+          <a:prstGeom prst="rect">
+            <a:avLst/>
+          </a:prstGeom>
+          <a:noFill/>
+          <a:ln/>
+        </p:spPr>
+        <p:txBody>
+          <a:bodyPr wrap="square" lIns="0" tIns="0" rIns="0" bIns="0" rtlCol="0" anchor="ctr"/>
+          <a:lstStyle/>
+          <a:p>
+            <a:pPr algn="ctr" indent="0" marL="0">
+              <a:buNone/>
+            </a:pPr>
+            <a:r>
+              <a:rPr lang="en-US" sz="1200" b="1" dirty="0">
+                <a:solidFill>
+                  <a:srgbClr val="FFFFFF"/>
+                </a:solidFill>
+                <a:latin typeface="Cambria" pitchFamily="34" charset="0"/>
+                <a:ea typeface="Cambria" pitchFamily="34" charset="-122"/>
+                <a:cs typeface="Cambria" pitchFamily="34" charset="-120"/>
+              </a:rPr>
+              <a:t>4</a:t>
+            </a:r>
+            <a:endParaRPr lang="en-US" sz="1200" dirty="0"/>
+          </a:p>
+        </p:txBody>
+      </p:sp>
+      <p:sp>
+        <p:nvSpPr>
+          <p:cNvPr id="23" name="Text 17"/>
+          <p:cNvSpPr/>
+          <p:nvPr/>
+        </p:nvSpPr>
+        <p:spPr>
+          <a:xfrm>
+            <a:off x="5152644" y="3493008"/>
+            <a:ext cx="1234440" cy="256032"/>
+          </a:xfrm>
+          <a:prstGeom prst="rect">
+            <a:avLst/>
+          </a:prstGeom>
+          <a:noFill/>
+          <a:ln/>
+        </p:spPr>
+        <p:txBody>
+          <a:bodyPr wrap="square" lIns="0" tIns="0" rIns="0" bIns="0" rtlCol="0" anchor="t"/>
+          <a:lstStyle/>
+          <a:p>
+            <a:pPr algn="ctr" indent="0" marL="0">
+              <a:buNone/>
+            </a:pPr>
+            <a:r>
+              <a:rPr lang="en-US" sz="1000" dirty="0">
+                <a:solidFill>
+                  <a:srgbClr val="9AA6B5"/>
+                </a:solidFill>
+                <a:latin typeface="Calibri" pitchFamily="34" charset="0"/>
+                <a:ea typeface="Calibri" pitchFamily="34" charset="-122"/>
+                <a:cs typeface="Calibri" pitchFamily="34" charset="-120"/>
+              </a:rPr>
+              <a:t>Sign in</a:t>
+            </a:r>
+            <a:endParaRPr lang="en-US" sz="1000" dirty="0"/>
+          </a:p>
+        </p:txBody>
+      </p:sp>
+      <p:sp>
+        <p:nvSpPr>
+          <p:cNvPr id="24" name="Shape 18"/>
+          <p:cNvSpPr/>
+          <p:nvPr/>
+        </p:nvSpPr>
+        <p:spPr>
+          <a:xfrm>
+            <a:off x="6400800" y="1513332"/>
+            <a:ext cx="1133856" cy="1956816"/>
+          </a:xfrm>
+          <a:prstGeom prst="roundRect">
+            <a:avLst>
+              <a:gd name="adj" fmla="val 4032"/>
+            </a:avLst>
+          </a:prstGeom>
+          <a:solidFill>
+            <a:srgbClr val="1E2632"/>
+          </a:solidFill>
+          <a:ln w="12700">
+            <a:solidFill>
+              <a:srgbClr val="2A3341"/>
+            </a:solidFill>
+            <a:prstDash val="solid"/>
+          </a:ln>
+          <a:effectLst>
+            <a:outerShdw sx="100000" sy="100000" kx="0" ky="0" algn="bl" rotWithShape="0" blurRad="88900" dist="25400" dir="5400000">
+              <a:srgbClr val="000000">
+                <a:alpha val="28000"/>
+              </a:srgbClr>
+            </a:outerShdw>
+          </a:effectLst>
+        </p:spPr>
+      </p:sp>
+      <p:pic>
+        <p:nvPicPr>
+          <p:cNvPr id="25" name="Image 4" descr="AltStore step 5: Install">    </p:cNvPr>
+          <p:cNvPicPr>
+            <a:picLocks noChangeAspect="1"/>
+          </p:cNvPicPr>
+          <p:nvPr/>
+        </p:nvPicPr>
+        <p:blipFill>
+          <a:blip r:embed="rId5"/>
+          <a:stretch>
+            <a:fillRect/>
+          </a:stretch>
+        </p:blipFill>
+        <p:spPr>
+          <a:xfrm>
+            <a:off x="6441948" y="1554480"/>
+            <a:ext cx="1051560" cy="1874520"/>
+          </a:xfrm>
+          <a:prstGeom prst="rect">
+            <a:avLst/>
+          </a:prstGeom>
+        </p:spPr>
+      </p:pic>
+      <p:sp>
+        <p:nvSpPr>
+          <p:cNvPr id="26" name="Shape 19"/>
+          <p:cNvSpPr/>
+          <p:nvPr/>
+        </p:nvSpPr>
+        <p:spPr>
+          <a:xfrm>
+            <a:off x="6423660" y="1444752"/>
+            <a:ext cx="292608" cy="292608"/>
+          </a:xfrm>
+          <a:prstGeom prst="ellipse">
+            <a:avLst/>
+          </a:prstGeom>
+          <a:solidFill>
+            <a:srgbClr val="E8552D"/>
+          </a:solidFill>
+          <a:ln w="19050">
+            <a:solidFill>
+              <a:srgbClr val="000000"/>
+            </a:solidFill>
+            <a:prstDash val="solid"/>
+          </a:ln>
+        </p:spPr>
+      </p:sp>
+      <p:sp>
+        <p:nvSpPr>
+          <p:cNvPr id="27" name="Text 20"/>
+          <p:cNvSpPr/>
+          <p:nvPr/>
+        </p:nvSpPr>
+        <p:spPr>
+          <a:xfrm>
+            <a:off x="6423660" y="1444752"/>
+            <a:ext cx="292608" cy="292608"/>
+          </a:xfrm>
+          <a:prstGeom prst="rect">
+            <a:avLst/>
+          </a:prstGeom>
+          <a:noFill/>
+          <a:ln/>
+        </p:spPr>
+        <p:txBody>
+          <a:bodyPr wrap="square" lIns="0" tIns="0" rIns="0" bIns="0" rtlCol="0" anchor="ctr"/>
+          <a:lstStyle/>
+          <a:p>
+            <a:pPr algn="ctr" indent="0" marL="0">
+              <a:buNone/>
+            </a:pPr>
+            <a:r>
+              <a:rPr lang="en-US" sz="1200" b="1" dirty="0">
+                <a:solidFill>
+                  <a:srgbClr val="FFFFFF"/>
+                </a:solidFill>
+                <a:latin typeface="Cambria" pitchFamily="34" charset="0"/>
+                <a:ea typeface="Cambria" pitchFamily="34" charset="-122"/>
+                <a:cs typeface="Cambria" pitchFamily="34" charset="-120"/>
+              </a:rPr>
+              <a:t>5</a:t>
+            </a:r>
+            <a:endParaRPr lang="en-US" sz="1200" dirty="0"/>
+          </a:p>
+        </p:txBody>
+      </p:sp>
+      <p:sp>
+        <p:nvSpPr>
+          <p:cNvPr id="28" name="Text 21"/>
+          <p:cNvSpPr/>
+          <p:nvPr/>
+        </p:nvSpPr>
+        <p:spPr>
+          <a:xfrm>
+            <a:off x="6350508" y="3493008"/>
+            <a:ext cx="1234440" cy="256032"/>
+          </a:xfrm>
+          <a:prstGeom prst="rect">
+            <a:avLst/>
+          </a:prstGeom>
+          <a:noFill/>
+          <a:ln/>
+        </p:spPr>
+        <p:txBody>
+          <a:bodyPr wrap="square" lIns="0" tIns="0" rIns="0" bIns="0" rtlCol="0" anchor="t"/>
+          <a:lstStyle/>
+          <a:p>
+            <a:pPr algn="ctr" indent="0" marL="0">
+              <a:buNone/>
+            </a:pPr>
+            <a:r>
+              <a:rPr lang="en-US" sz="1000" dirty="0">
+                <a:solidFill>
+                  <a:srgbClr val="9AA6B5"/>
+                </a:solidFill>
+                <a:latin typeface="Calibri" pitchFamily="34" charset="0"/>
+                <a:ea typeface="Calibri" pitchFamily="34" charset="-122"/>
+                <a:cs typeface="Calibri" pitchFamily="34" charset="-120"/>
+              </a:rPr>
+              <a:t>Install</a:t>
+            </a:r>
+            <a:endParaRPr lang="en-US" sz="1000" dirty="0"/>
+          </a:p>
+        </p:txBody>
+      </p:sp>
+      <p:sp>
+        <p:nvSpPr>
+          <p:cNvPr id="29" name="Shape 22"/>
+          <p:cNvSpPr/>
+          <p:nvPr/>
+        </p:nvSpPr>
+        <p:spPr>
+          <a:xfrm>
+            <a:off x="502920" y="3767328"/>
+            <a:ext cx="8138160" cy="822960"/>
+          </a:xfrm>
+          <a:prstGeom prst="roundRect">
+            <a:avLst>
+              <a:gd name="adj" fmla="val 10000"/>
             </a:avLst>
           </a:prstGeom>
           <a:solidFill>
@@ -12727,65 +13494,14 @@
       </p:sp>
       <p:sp>
         <p:nvSpPr>
-          <p:cNvPr id="6" name="Shape 4"/>
-          <p:cNvSpPr/>
-          <p:nvPr/>
-        </p:nvSpPr>
-        <p:spPr>
-          <a:xfrm>
-            <a:off x="6080760" y="2221992"/>
-            <a:ext cx="603504" cy="603504"/>
-          </a:xfrm>
-          <a:prstGeom prst="ellipse">
-            <a:avLst/>
-          </a:prstGeom>
-          <a:solidFill>
-            <a:srgbClr val="E8552D"/>
-          </a:solidFill>
-          <a:ln/>
-          <a:effectLst>
-            <a:outerShdw sx="100000" sy="100000" kx="0" ky="0" algn="bl" rotWithShape="0" blurRad="76200" dist="25400" dir="5400000">
-              <a:srgbClr val="000000">
-                <a:alpha val="18000"/>
-              </a:srgbClr>
-            </a:outerShdw>
-          </a:effectLst>
-        </p:spPr>
-      </p:sp>
-      <p:pic>
-        <p:nvPicPr>
-          <p:cNvPr id="7" name="Image 0" descr="preencoded.png">    </p:cNvPr>
-          <p:cNvPicPr>
-            <a:picLocks noChangeAspect="1"/>
-          </p:cNvPicPr>
-          <p:nvPr/>
-        </p:nvPicPr>
-        <p:blipFill>
-          <a:blip r:embed="rId1"/>
-          <a:stretch>
-            <a:fillRect/>
-          </a:stretch>
-        </p:blipFill>
-        <p:spPr>
-          <a:xfrm>
-            <a:off x="6237671" y="2378903"/>
-            <a:ext cx="289682" cy="289682"/>
-          </a:xfrm>
-          <a:prstGeom prst="rect">
-            <a:avLst/>
-          </a:prstGeom>
-        </p:spPr>
-      </p:pic>
-      <p:sp>
-        <p:nvSpPr>
-          <p:cNvPr id="8" name="Text 5"/>
-          <p:cNvSpPr/>
-          <p:nvPr/>
-        </p:nvSpPr>
-        <p:spPr>
-          <a:xfrm>
-            <a:off x="6080760" y="2926080"/>
-            <a:ext cx="2286000" cy="502920"/>
+          <p:cNvPr id="30" name="Text 23"/>
+          <p:cNvSpPr/>
+          <p:nvPr/>
+        </p:nvSpPr>
+        <p:spPr>
+          <a:xfrm>
+            <a:off x="777240" y="3840480"/>
+            <a:ext cx="7589520" cy="420624"/>
           </a:xfrm>
           <a:prstGeom prst="rect">
             <a:avLst/>
@@ -12797,53 +13513,31 @@
           <a:bodyPr wrap="square" lIns="0" tIns="0" rIns="0" bIns="0" rtlCol="0" anchor="ctr"/>
           <a:lstStyle/>
           <a:p>
-            <a:pPr indent="0" marL="0">
-              <a:buNone/>
-            </a:pPr>
-            <a:r>
-              <a:rPr lang="en-US" sz="2200" b="1" dirty="0">
-                <a:solidFill>
-                  <a:srgbClr val="EAEFF5"/>
-                </a:solidFill>
-                <a:latin typeface="Cambria" pitchFamily="34" charset="0"/>
-                <a:ea typeface="Cambria" pitchFamily="34" charset="-122"/>
-                <a:cs typeface="Cambria" pitchFamily="34" charset="-120"/>
-              </a:rPr>
-              <a:t>Let's talk</a:t>
-            </a:r>
-            <a:endParaRPr lang="en-US" sz="2200" dirty="0"/>
-          </a:p>
-        </p:txBody>
-      </p:sp>
-      <p:sp>
-        <p:nvSpPr>
-          <p:cNvPr id="9" name="Text 6"/>
-          <p:cNvSpPr/>
-          <p:nvPr/>
-        </p:nvSpPr>
-        <p:spPr>
-          <a:xfrm>
-            <a:off x="6080760" y="3447288"/>
-            <a:ext cx="2240280" cy="777240"/>
-          </a:xfrm>
-          <a:prstGeom prst="rect">
-            <a:avLst/>
-          </a:prstGeom>
-          <a:noFill/>
-          <a:ln/>
-        </p:spPr>
-        <p:txBody>
-          <a:bodyPr wrap="square" lIns="0" tIns="0" rIns="0" bIns="0" rtlCol="0" anchor="t"/>
-          <a:lstStyle/>
-          <a:p>
-            <a:pPr indent="0" marL="0">
+            <a:pPr algn="l" indent="0" marL="0">
               <a:lnSpc>
-                <a:spcPct val="106000"/>
+                <a:spcPct val="102000"/>
               </a:lnSpc>
               <a:buNone/>
             </a:pPr>
             <a:r>
-              <a:rPr lang="en-US" sz="1300" dirty="0">
+              <a:rPr lang="en-US" sz="1150" b="1" dirty="0">
+                <a:solidFill>
+                  <a:srgbClr val="1FB3A6"/>
+                </a:solidFill>
+                <a:latin typeface="Calibri" pitchFamily="34" charset="0"/>
+                <a:ea typeface="Calibri" pitchFamily="34" charset="-122"/>
+                <a:cs typeface="Calibri" pitchFamily="34" charset="-120"/>
+              </a:rPr>
+              <a:t>SideStore</a:t>
+            </a:r>
+            <a:pPr algn="l" indent="0" marL="0">
+              <a:lnSpc>
+                <a:spcPct val="102000"/>
+              </a:lnSpc>
+              <a:buNone/>
+            </a:pPr>
+            <a:r>
+              <a:rPr lang="en-US" sz="1150" dirty="0">
                 <a:solidFill>
                   <a:srgbClr val="9AA8B8"/>
                 </a:solidFill>
@@ -12851,15 +13545,75 @@
                 <a:ea typeface="Calibri" pitchFamily="34" charset="-122"/>
                 <a:cs typeface="Calibri" pitchFamily="34" charset="-120"/>
               </a:rPr>
-              <a:t>Find me at EuroTcl — during the break or after the talk.</a:t>
-            </a:r>
-            <a:endParaRPr lang="en-US" sz="1300" dirty="0"/>
-          </a:p>
-        </p:txBody>
-      </p:sp>
-      <p:sp>
-        <p:nvSpPr>
-          <p:cNvPr id="10" name="Text 7"/>
+              <a:t> — an AltStore fork that re-signs apps on-device (no computer needed after the first pairing), so your 7-day sideload keeps renewing by itself.</a:t>
+            </a:r>
+            <a:endParaRPr lang="en-US" sz="1150" dirty="0"/>
+          </a:p>
+        </p:txBody>
+      </p:sp>
+      <p:sp>
+        <p:nvSpPr>
+          <p:cNvPr id="31" name="Text 24"/>
+          <p:cNvSpPr/>
+          <p:nvPr/>
+        </p:nvSpPr>
+        <p:spPr>
+          <a:xfrm>
+            <a:off x="777240" y="4261104"/>
+            <a:ext cx="7589520" cy="274320"/>
+          </a:xfrm>
+          <a:prstGeom prst="rect">
+            <a:avLst/>
+          </a:prstGeom>
+          <a:noFill/>
+          <a:ln/>
+        </p:spPr>
+        <p:txBody>
+          <a:bodyPr wrap="square" lIns="0" tIns="0" rIns="0" bIns="0" rtlCol="0" anchor="ctr"/>
+          <a:lstStyle/>
+          <a:p>
+            <a:pPr algn="l" indent="0" marL="0">
+              <a:buNone/>
+            </a:pPr>
+            <a:r>
+              <a:rPr lang="en-US" sz="1100" dirty="0">
+                <a:solidFill>
+                  <a:srgbClr val="9AA6B5"/>
+                </a:solidFill>
+                <a:latin typeface="Calibri" pitchFamily="34" charset="0"/>
+                <a:ea typeface="Calibri" pitchFamily="34" charset="-122"/>
+                <a:cs typeface="Calibri" pitchFamily="34" charset="-120"/>
+              </a:rPr>
+              <a:t>Full AltStore setup guide (macOS): </a:t>
+            </a:r>
+            <a:pPr algn="l" indent="0" marL="0">
+              <a:buNone/>
+            </a:pPr>
+            <a:r>
+              <a:rPr lang="en-US" sz="1100" b="1" u="sng" dirty="0">
+                <a:solidFill>
+                  <a:srgbClr val="E8552D"/>
+                </a:solidFill>
+                <a:latin typeface="Calibri" pitchFamily="34" charset="0"/>
+                <a:ea typeface="Calibri" pitchFamily="34" charset="-122"/>
+                <a:cs typeface="Calibri" pitchFamily="34" charset="-120"/>
+                <a:hlinkClick r:id="rId6" invalidUrl="" action="" tgtFrame="" tooltip="" history="1" highlightClick="0" endSnd="0">
+                  <a:extLst>
+                    <a:ext uri="{A12FA001-AC4F-418D-AE19-62706E023703}">
+                      <ahyp:hlinkClr xmlns:ahyp="http://schemas.microsoft.com/office/drawing/2018/hyperlinkcolor" val="tx"/>
+                    </a:ext>
+                  </a:extLst>
+                </a:hlinkClick>
+              </a:rPr>
+              <a:t>faq.altstore.io/altstore-classic/how-to-install-altstore-macos</a:t>
+            </a:r>
+            <a:endParaRPr lang="en-US" sz="1100" dirty="0"/>
+          </a:p>
+        </p:txBody>
+      </p:sp>
+      <p:sp>
+        <p:nvSpPr>
+          <p:cNvPr id="32" name="Text 25"/>
           <p:cNvSpPr/>
           <p:nvPr/>
         </p:nvSpPr>
@@ -12912,7 +13666,7 @@
       </p:sp>
       <p:sp>
         <p:nvSpPr>
-          <p:cNvPr id="11" name="Text 8"/>
+          <p:cNvPr id="33" name="Text 26"/>
           <p:cNvSpPr/>
           <p:nvPr/>
         </p:nvSpPr>
@@ -12983,6 +13737,504 @@
       </p:grpSpPr>
       <p:sp>
         <p:nvSpPr>
+          <p:cNvPr id="2" name="Text 0"/>
+          <p:cNvSpPr/>
+          <p:nvPr/>
+        </p:nvSpPr>
+        <p:spPr>
+          <a:xfrm>
+            <a:off x="502920" y="384048"/>
+            <a:ext cx="8138160" cy="274320"/>
+          </a:xfrm>
+          <a:prstGeom prst="rect">
+            <a:avLst/>
+          </a:prstGeom>
+          <a:noFill/>
+          <a:ln/>
+        </p:spPr>
+        <p:txBody>
+          <a:bodyPr wrap="square" lIns="0" tIns="0" rIns="0" bIns="0" rtlCol="0" anchor="ctr"/>
+          <a:lstStyle/>
+          <a:p>
+            <a:pPr algn="l" indent="0" marL="0">
+              <a:buNone/>
+            </a:pPr>
+            <a:r>
+              <a:rPr lang="en-US" sz="1200" b="1" spc="250" kern="0" dirty="0">
+                <a:solidFill>
+                  <a:srgbClr val="E8552D"/>
+                </a:solidFill>
+                <a:latin typeface="Calibri" pitchFamily="34" charset="0"/>
+                <a:ea typeface="Calibri" pitchFamily="34" charset="-122"/>
+                <a:cs typeface="Calibri" pitchFamily="34" charset="-120"/>
+              </a:rPr>
+              <a:t>CALL FOR COLLABORATORS</a:t>
+            </a:r>
+            <a:endParaRPr lang="en-US" sz="1200" dirty="0"/>
+          </a:p>
+        </p:txBody>
+      </p:sp>
+      <p:sp>
+        <p:nvSpPr>
+          <p:cNvPr id="3" name="Text 1"/>
+          <p:cNvSpPr/>
+          <p:nvPr/>
+        </p:nvSpPr>
+        <p:spPr>
+          <a:xfrm>
+            <a:off x="502920" y="658368"/>
+            <a:ext cx="8138160" cy="777240"/>
+          </a:xfrm>
+          <a:prstGeom prst="rect">
+            <a:avLst/>
+          </a:prstGeom>
+          <a:noFill/>
+          <a:ln/>
+        </p:spPr>
+        <p:txBody>
+          <a:bodyPr wrap="square" lIns="0" tIns="0" rIns="0" bIns="0" rtlCol="0" anchor="t"/>
+          <a:lstStyle/>
+          <a:p>
+            <a:pPr algn="l" indent="0" marL="0">
+              <a:lnSpc>
+                <a:spcPct val="98000"/>
+              </a:lnSpc>
+              <a:buNone/>
+            </a:pPr>
+            <a:r>
+              <a:rPr lang="en-US" sz="3000" b="1" dirty="0">
+                <a:solidFill>
+                  <a:srgbClr val="ECEFF4"/>
+                </a:solidFill>
+                <a:latin typeface="Cambria" pitchFamily="34" charset="0"/>
+                <a:ea typeface="Cambria" pitchFamily="34" charset="-122"/>
+                <a:cs typeface="Cambria" pitchFamily="34" charset="-120"/>
+              </a:rPr>
+              <a:t>Wanted: an EU Company (or Org) to help distribute a free Tcl/Tk without limitations</a:t>
+            </a:r>
+            <a:endParaRPr lang="en-US" sz="3000" dirty="0"/>
+          </a:p>
+        </p:txBody>
+      </p:sp>
+      <p:sp>
+        <p:nvSpPr>
+          <p:cNvPr id="4" name="Text 2"/>
+          <p:cNvSpPr/>
+          <p:nvPr/>
+        </p:nvSpPr>
+        <p:spPr>
+          <a:xfrm>
+            <a:off x="502920" y="1965960"/>
+            <a:ext cx="5029200" cy="2377440"/>
+          </a:xfrm>
+          <a:prstGeom prst="rect">
+            <a:avLst/>
+          </a:prstGeom>
+          <a:noFill/>
+          <a:ln/>
+        </p:spPr>
+        <p:txBody>
+          <a:bodyPr wrap="square" lIns="0" tIns="0" rIns="0" bIns="0" rtlCol="0" anchor="t"/>
+          <a:lstStyle/>
+          <a:p>
+            <a:pPr algn="l" marL="203200" indent="-203200">
+              <a:spcAft>
+                <a:spcPts val="800"/>
+              </a:spcAft>
+              <a:buSzPct val="100000"/>
+              <a:buChar char="•"/>
+            </a:pPr>
+            <a:r>
+              <a:rPr lang="en-US" sz="1400" b="1" dirty="0">
+                <a:solidFill>
+                  <a:srgbClr val="ECEFF4"/>
+                </a:solidFill>
+                <a:latin typeface="Calibri" pitchFamily="34" charset="0"/>
+                <a:ea typeface="Calibri" pitchFamily="34" charset="-122"/>
+                <a:cs typeface="Calibri" pitchFamily="34" charset="-120"/>
+              </a:rPr>
+              <a:t>I'm looking for a partner with an EU-registered company</a:t>
+            </a:r>
+            <a:endParaRPr lang="en-US" sz="1400" dirty="0"/>
+          </a:p>
+          <a:p>
+            <a:pPr algn="l" marL="203200" indent="-203200">
+              <a:spcAft>
+                <a:spcPts val="800"/>
+              </a:spcAft>
+              <a:buSzPct val="100000"/>
+              <a:buChar char="•"/>
+            </a:pPr>
+            <a:r>
+              <a:rPr lang="en-US" sz="1400" dirty="0">
+                <a:solidFill>
+                  <a:srgbClr val="ECEFF4"/>
+                </a:solidFill>
+                <a:latin typeface="Calibri" pitchFamily="34" charset="0"/>
+                <a:ea typeface="Calibri" pitchFamily="34" charset="-122"/>
+                <a:cs typeface="Calibri" pitchFamily="34" charset="-120"/>
+              </a:rPr>
+              <a:t>…willing to sign Apple's distribution paperwork</a:t>
+            </a:r>
+            <a:endParaRPr lang="en-US" sz="1400" dirty="0"/>
+          </a:p>
+          <a:p>
+            <a:pPr algn="l" marL="203200" indent="-203200">
+              <a:spcAft>
+                <a:spcPts val="800"/>
+              </a:spcAft>
+              <a:buSzPct val="100000"/>
+              <a:buChar char="•"/>
+            </a:pPr>
+            <a:r>
+              <a:rPr lang="en-US" sz="1400" dirty="0">
+                <a:solidFill>
+                  <a:srgbClr val="ECEFF4"/>
+                </a:solidFill>
+                <a:latin typeface="Calibri" pitchFamily="34" charset="0"/>
+                <a:ea typeface="Calibri" pitchFamily="34" charset="-122"/>
+                <a:cs typeface="Calibri" pitchFamily="34" charset="-120"/>
+              </a:rPr>
+              <a:t>Then we ship a notarized IPA for open sideloading</a:t>
+            </a:r>
+            <a:endParaRPr lang="en-US" sz="1400" dirty="0"/>
+          </a:p>
+          <a:p>
+            <a:pPr algn="l" marL="203200" indent="-203200">
+              <a:spcAft>
+                <a:spcPts val="800"/>
+              </a:spcAft>
+              <a:buSzPct val="100000"/>
+              <a:buChar char="•"/>
+            </a:pPr>
+            <a:r>
+              <a:rPr lang="en-US" sz="1400" dirty="0">
+                <a:solidFill>
+                  <a:srgbClr val="ECEFF4"/>
+                </a:solidFill>
+                <a:latin typeface="Calibri" pitchFamily="34" charset="0"/>
+                <a:ea typeface="Calibri" pitchFamily="34" charset="-122"/>
+                <a:cs typeface="Calibri" pitchFamily="34" charset="-120"/>
+              </a:rPr>
+              <a:t>Europeans get iWish + the DE1 app — no 7-day expiry, no device cap</a:t>
+            </a:r>
+            <a:endParaRPr lang="en-US" sz="1400" dirty="0"/>
+          </a:p>
+          <a:p>
+            <a:pPr algn="l" marL="203200" indent="-203200">
+              <a:spcAft>
+                <a:spcPts val="800"/>
+              </a:spcAft>
+              <a:buSzPct val="100000"/>
+              <a:buChar char="•"/>
+            </a:pPr>
+            <a:r>
+              <a:rPr lang="en-US" sz="1400" dirty="0">
+                <a:solidFill>
+                  <a:srgbClr val="ECEFF4"/>
+                </a:solidFill>
+                <a:latin typeface="Calibri" pitchFamily="34" charset="0"/>
+                <a:ea typeface="Calibri" pitchFamily="34" charset="-122"/>
+                <a:cs typeface="Calibri" pitchFamily="34" charset="-120"/>
+              </a:rPr>
+              <a:t>You're the EU entity of record; I bring the app and the work</a:t>
+            </a:r>
+            <a:endParaRPr lang="en-US" sz="1400" dirty="0"/>
+          </a:p>
+        </p:txBody>
+      </p:sp>
+      <p:sp>
+        <p:nvSpPr>
+          <p:cNvPr id="5" name="Shape 3"/>
+          <p:cNvSpPr/>
+          <p:nvPr/>
+        </p:nvSpPr>
+        <p:spPr>
+          <a:xfrm>
+            <a:off x="5806440" y="1965960"/>
+            <a:ext cx="2834640" cy="2331720"/>
+          </a:xfrm>
+          <a:prstGeom prst="roundRect">
+            <a:avLst>
+              <a:gd name="adj" fmla="val 3529"/>
+            </a:avLst>
+          </a:prstGeom>
+          <a:solidFill>
+            <a:srgbClr val="141A24"/>
+          </a:solidFill>
+          <a:ln w="12700">
+            <a:solidFill>
+              <a:srgbClr val="2A3341"/>
+            </a:solidFill>
+            <a:prstDash val="solid"/>
+          </a:ln>
+          <a:effectLst>
+            <a:outerShdw sx="100000" sy="100000" kx="0" ky="0" algn="bl" rotWithShape="0" blurRad="101600" dist="38100" dir="5400000">
+              <a:srgbClr val="000000">
+                <a:alpha val="10000"/>
+              </a:srgbClr>
+            </a:outerShdw>
+          </a:effectLst>
+        </p:spPr>
+      </p:sp>
+      <p:sp>
+        <p:nvSpPr>
+          <p:cNvPr id="6" name="Shape 4"/>
+          <p:cNvSpPr/>
+          <p:nvPr/>
+        </p:nvSpPr>
+        <p:spPr>
+          <a:xfrm>
+            <a:off x="6080760" y="2221992"/>
+            <a:ext cx="603504" cy="603504"/>
+          </a:xfrm>
+          <a:prstGeom prst="ellipse">
+            <a:avLst/>
+          </a:prstGeom>
+          <a:solidFill>
+            <a:srgbClr val="E8552D"/>
+          </a:solidFill>
+          <a:ln/>
+          <a:effectLst>
+            <a:outerShdw sx="100000" sy="100000" kx="0" ky="0" algn="bl" rotWithShape="0" blurRad="76200" dist="25400" dir="5400000">
+              <a:srgbClr val="000000">
+                <a:alpha val="18000"/>
+              </a:srgbClr>
+            </a:outerShdw>
+          </a:effectLst>
+        </p:spPr>
+      </p:sp>
+      <p:pic>
+        <p:nvPicPr>
+          <p:cNvPr id="7" name="Image 0" descr="preencoded.png">    </p:cNvPr>
+          <p:cNvPicPr>
+            <a:picLocks noChangeAspect="1"/>
+          </p:cNvPicPr>
+          <p:nvPr/>
+        </p:nvPicPr>
+        <p:blipFill>
+          <a:blip r:embed="rId1"/>
+          <a:stretch>
+            <a:fillRect/>
+          </a:stretch>
+        </p:blipFill>
+        <p:spPr>
+          <a:xfrm>
+            <a:off x="6237671" y="2378903"/>
+            <a:ext cx="289682" cy="289682"/>
+          </a:xfrm>
+          <a:prstGeom prst="rect">
+            <a:avLst/>
+          </a:prstGeom>
+        </p:spPr>
+      </p:pic>
+      <p:sp>
+        <p:nvSpPr>
+          <p:cNvPr id="8" name="Text 5"/>
+          <p:cNvSpPr/>
+          <p:nvPr/>
+        </p:nvSpPr>
+        <p:spPr>
+          <a:xfrm>
+            <a:off x="6080760" y="2926080"/>
+            <a:ext cx="2286000" cy="502920"/>
+          </a:xfrm>
+          <a:prstGeom prst="rect">
+            <a:avLst/>
+          </a:prstGeom>
+          <a:noFill/>
+          <a:ln/>
+        </p:spPr>
+        <p:txBody>
+          <a:bodyPr wrap="square" lIns="0" tIns="0" rIns="0" bIns="0" rtlCol="0" anchor="ctr"/>
+          <a:lstStyle/>
+          <a:p>
+            <a:pPr indent="0" marL="0">
+              <a:buNone/>
+            </a:pPr>
+            <a:r>
+              <a:rPr lang="en-US" sz="2200" b="1" dirty="0">
+                <a:solidFill>
+                  <a:srgbClr val="EAEFF5"/>
+                </a:solidFill>
+                <a:latin typeface="Cambria" pitchFamily="34" charset="0"/>
+                <a:ea typeface="Cambria" pitchFamily="34" charset="-122"/>
+                <a:cs typeface="Cambria" pitchFamily="34" charset="-120"/>
+              </a:rPr>
+              <a:t>Let's talk</a:t>
+            </a:r>
+            <a:endParaRPr lang="en-US" sz="2200" dirty="0"/>
+          </a:p>
+        </p:txBody>
+      </p:sp>
+      <p:sp>
+        <p:nvSpPr>
+          <p:cNvPr id="9" name="Text 6"/>
+          <p:cNvSpPr/>
+          <p:nvPr/>
+        </p:nvSpPr>
+        <p:spPr>
+          <a:xfrm>
+            <a:off x="6080760" y="3447288"/>
+            <a:ext cx="2240280" cy="777240"/>
+          </a:xfrm>
+          <a:prstGeom prst="rect">
+            <a:avLst/>
+          </a:prstGeom>
+          <a:noFill/>
+          <a:ln/>
+        </p:spPr>
+        <p:txBody>
+          <a:bodyPr wrap="square" lIns="0" tIns="0" rIns="0" bIns="0" rtlCol="0" anchor="t"/>
+          <a:lstStyle/>
+          <a:p>
+            <a:pPr indent="0" marL="0">
+              <a:lnSpc>
+                <a:spcPct val="106000"/>
+              </a:lnSpc>
+              <a:buNone/>
+            </a:pPr>
+            <a:r>
+              <a:rPr lang="en-US" sz="1300" dirty="0">
+                <a:solidFill>
+                  <a:srgbClr val="9AA8B8"/>
+                </a:solidFill>
+                <a:latin typeface="Calibri" pitchFamily="34" charset="0"/>
+                <a:ea typeface="Calibri" pitchFamily="34" charset="-122"/>
+                <a:cs typeface="Calibri" pitchFamily="34" charset="-120"/>
+              </a:rPr>
+              <a:t>Find me at EuroTcl — during the break or after the talk.</a:t>
+            </a:r>
+            <a:endParaRPr lang="en-US" sz="1300" dirty="0"/>
+          </a:p>
+        </p:txBody>
+      </p:sp>
+      <p:sp>
+        <p:nvSpPr>
+          <p:cNvPr id="10" name="Text 7"/>
+          <p:cNvSpPr/>
+          <p:nvPr/>
+        </p:nvSpPr>
+        <p:spPr>
+          <a:xfrm>
+            <a:off x="502920" y="4736592"/>
+            <a:ext cx="6400800" cy="274320"/>
+          </a:xfrm>
+          <a:prstGeom prst="rect">
+            <a:avLst/>
+          </a:prstGeom>
+          <a:noFill/>
+          <a:ln/>
+        </p:spPr>
+        <p:txBody>
+          <a:bodyPr wrap="square" lIns="0" tIns="0" rIns="0" bIns="0" rtlCol="0" anchor="ctr"/>
+          <a:lstStyle/>
+          <a:p>
+            <a:pPr algn="l" indent="0" marL="0">
+              <a:buNone/>
+            </a:pPr>
+            <a:r>
+              <a:rPr lang="en-US" sz="900" b="1" dirty="0">
+                <a:solidFill>
+                  <a:srgbClr val="E8552D"/>
+                </a:solidFill>
+                <a:latin typeface="Calibri" pitchFamily="34" charset="0"/>
+                <a:ea typeface="Calibri" pitchFamily="34" charset="-122"/>
+                <a:cs typeface="Calibri" pitchFamily="34" charset="-120"/>
+              </a:rPr>
+              <a:t>EuroTcl 2026</a:t>
+            </a:r>
+            <a:pPr algn="l" indent="0" marL="0">
+              <a:buNone/>
+            </a:pPr>
+            <a:r>
+              <a:rPr lang="en-US" sz="900" dirty="0">
+                <a:solidFill>
+                  <a:srgbClr val="9AA6B5"/>
+                </a:solidFill>
+                <a:latin typeface="Calibri" pitchFamily="34" charset="0"/>
+                <a:ea typeface="Calibri" pitchFamily="34" charset="-122"/>
+                <a:cs typeface="Calibri" pitchFamily="34" charset="-120"/>
+              </a:rPr>
+              <a:t>   iWish for iOS</a:t>
+            </a:r>
+            <a:endParaRPr lang="en-US" sz="900" dirty="0"/>
+          </a:p>
+        </p:txBody>
+      </p:sp>
+      <p:sp>
+        <p:nvSpPr>
+          <p:cNvPr id="11" name="Text 8"/>
+          <p:cNvSpPr/>
+          <p:nvPr/>
+        </p:nvSpPr>
+        <p:spPr>
+          <a:xfrm>
+            <a:off x="8229600" y="4736592"/>
+            <a:ext cx="411480" cy="274320"/>
+          </a:xfrm>
+          <a:prstGeom prst="rect">
+            <a:avLst/>
+          </a:prstGeom>
+          <a:noFill/>
+          <a:ln/>
+        </p:spPr>
+        <p:txBody>
+          <a:bodyPr wrap="square" lIns="0" tIns="0" rIns="0" bIns="0" rtlCol="0" anchor="ctr"/>
+          <a:lstStyle/>
+          <a:p>
+            <a:pPr algn="r" indent="0" marL="0">
+              <a:buNone/>
+            </a:pPr>
+            <a:r>
+              <a:rPr lang="en-US" sz="900" dirty="0">
+                <a:solidFill>
+                  <a:srgbClr val="9AA6B5"/>
+                </a:solidFill>
+                <a:latin typeface="Calibri" pitchFamily="34" charset="0"/>
+                <a:ea typeface="Calibri" pitchFamily="34" charset="-122"/>
+                <a:cs typeface="Calibri" pitchFamily="34" charset="-120"/>
+              </a:rPr>
+              <a:t>20</a:t>
+            </a:r>
+            <a:endParaRPr lang="en-US" sz="900" dirty="0"/>
+          </a:p>
+        </p:txBody>
+      </p:sp>
+    </p:spTree>
+  </p:cSld>
+  <p:clrMapOvr>
+    <a:masterClrMapping/>
+  </p:clrMapOvr>
+</p:sld>
+</file>
+
+<file path=ppt/slides/slide24.xml><?xml version="1.0" encoding="utf-8"?>
+<p:sld xmlns:a="http://schemas.openxmlformats.org/drawingml/2006/main" xmlns:r="http://schemas.openxmlformats.org/officeDocument/2006/relationships" xmlns:p="http://schemas.openxmlformats.org/presentationml/2006/main">
+  <p:cSld name="Slide 24">
+    <p:bg>
+      <p:bgPr>
+        <a:solidFill>
+          <a:srgbClr val="000000"/>
+        </a:solidFill>
+      </p:bgPr>
+    </p:bg>
+    <p:spTree>
+      <p:nvGrpSpPr>
+        <p:cNvPr id="1" name=""/>
+        <p:cNvGrpSpPr/>
+        <p:nvPr/>
+      </p:nvGrpSpPr>
+      <p:grpSpPr>
+        <a:xfrm>
+          <a:off x="0" y="0"/>
+          <a:ext cx="0" cy="0"/>
+          <a:chOff x="0" y="0"/>
+          <a:chExt cx="0" cy="0"/>
+        </a:xfrm>
+      </p:grpSpPr>
+      <p:sp>
+        <p:nvSpPr>
           <p:cNvPr id="2" name="Shape 0"/>
           <p:cNvSpPr/>
           <p:nvPr/>
@@ -15850,7 +17102,7 @@
         <p:spPr>
           <a:xfrm>
             <a:off x="502920" y="1554480"/>
-            <a:ext cx="4937760" cy="2834640"/>
+            <a:ext cx="4754880" cy="2834640"/>
           </a:xfrm>
           <a:prstGeom prst="rect">
             <a:avLst/>
@@ -15983,16 +17235,16 @@
         </p:nvSpPr>
         <p:spPr>
           <a:xfrm>
-            <a:off x="5715000" y="1554480"/>
-            <a:ext cx="2926080" cy="2743200"/>
+            <a:off x="5468112" y="1700784"/>
+            <a:ext cx="3236976" cy="2459736"/>
           </a:xfrm>
           <a:prstGeom prst="roundRect">
             <a:avLst>
-              <a:gd name="adj" fmla="val 3000"/>
+              <a:gd name="adj" fmla="val 2230"/>
             </a:avLst>
           </a:prstGeom>
           <a:solidFill>
-            <a:srgbClr val="0F141D"/>
+            <a:srgbClr val="1E2632"/>
           </a:solidFill>
           <a:ln w="12700">
             <a:solidFill>
@@ -16001,44 +17253,17 @@
             <a:prstDash val="solid"/>
           </a:ln>
           <a:effectLst>
-            <a:outerShdw sx="100000" sy="100000" kx="0" ky="0" algn="bl" rotWithShape="0" blurRad="101600" dist="38100" dir="5400000">
+            <a:outerShdw sx="100000" sy="100000" kx="0" ky="0" algn="bl" rotWithShape="0" blurRad="139700" dist="38100" dir="5400000">
               <a:srgbClr val="000000">
-                <a:alpha val="10000"/>
+                <a:alpha val="32000"/>
               </a:srgbClr>
             </a:outerShdw>
           </a:effectLst>
         </p:spPr>
       </p:sp>
-      <p:sp>
-        <p:nvSpPr>
-          <p:cNvPr id="6" name="Shape 4"/>
-          <p:cNvSpPr/>
-          <p:nvPr/>
-        </p:nvSpPr>
-        <p:spPr>
-          <a:xfrm>
-            <a:off x="5989320" y="1801368"/>
-            <a:ext cx="658368" cy="658368"/>
-          </a:xfrm>
-          <a:prstGeom prst="ellipse">
-            <a:avLst/>
-          </a:prstGeom>
-          <a:solidFill>
-            <a:srgbClr val="1FB3A6"/>
-          </a:solidFill>
-          <a:ln/>
-          <a:effectLst>
-            <a:outerShdw sx="100000" sy="100000" kx="0" ky="0" algn="bl" rotWithShape="0" blurRad="76200" dist="25400" dir="5400000">
-              <a:srgbClr val="000000">
-                <a:alpha val="18000"/>
-              </a:srgbClr>
-            </a:outerShdw>
-          </a:effectLst>
-        </p:spPr>
-      </p:sp>
       <p:pic>
         <p:nvPicPr>
-          <p:cNvPr id="7" name="Image 0" descr="preencoded.png">    </p:cNvPr>
+          <p:cNvPr id="6" name="Image 0" descr="iWish on an iPad2,5 (iPad mini 1, armv7) running iOS 9.3.5 — borg bridge, BLE debugger to a Decent Scale, and a wish console">    </p:cNvPr>
           <p:cNvPicPr>
             <a:picLocks noChangeAspect="1"/>
           </p:cNvPicPr>
@@ -16052,8 +17277,8 @@
         </p:blipFill>
         <p:spPr>
           <a:xfrm>
-            <a:off x="6160496" y="1972544"/>
-            <a:ext cx="316017" cy="316017"/>
+            <a:off x="5532120" y="1764792"/>
+            <a:ext cx="3108960" cy="2331720"/>
           </a:xfrm>
           <a:prstGeom prst="rect">
             <a:avLst/>
@@ -16062,88 +17287,46 @@
       </p:pic>
       <p:sp>
         <p:nvSpPr>
+          <p:cNvPr id="7" name="Text 4"/>
+          <p:cNvSpPr/>
+          <p:nvPr/>
+        </p:nvSpPr>
+        <p:spPr>
+          <a:xfrm>
+            <a:off x="5532120" y="4187952"/>
+            <a:ext cx="3108960" cy="237744"/>
+          </a:xfrm>
+          <a:prstGeom prst="rect">
+            <a:avLst/>
+          </a:prstGeom>
+          <a:noFill/>
+          <a:ln/>
+        </p:spPr>
+        <p:txBody>
+          <a:bodyPr wrap="square" lIns="0" tIns="0" rIns="0" bIns="0" rtlCol="0" anchor="ctr"/>
+          <a:lstStyle/>
+          <a:p>
+            <a:pPr algn="ctr" indent="0" marL="0">
+              <a:buNone/>
+            </a:pPr>
+            <a:r>
+              <a:rPr lang="en-US" sz="1050" i="1" dirty="0">
+                <a:solidFill>
+                  <a:srgbClr val="9AA6B5"/>
+                </a:solidFill>
+                <a:latin typeface="Calibri" pitchFamily="34" charset="0"/>
+                <a:ea typeface="Calibri" pitchFamily="34" charset="-122"/>
+                <a:cs typeface="Calibri" pitchFamily="34" charset="-120"/>
+              </a:rPr>
+              <a:t>iPad2,5 · armv7 · iOS 9.3.5</a:t>
+            </a:r>
+            <a:endParaRPr lang="en-US" sz="1050" dirty="0"/>
+          </a:p>
+        </p:txBody>
+      </p:sp>
+      <p:sp>
+        <p:nvSpPr>
           <p:cNvPr id="8" name="Text 5"/>
-          <p:cNvSpPr/>
-          <p:nvPr/>
-        </p:nvSpPr>
-        <p:spPr>
-          <a:xfrm>
-            <a:off x="6812280" y="1874520"/>
-            <a:ext cx="1737360" cy="502920"/>
-          </a:xfrm>
-          <a:prstGeom prst="rect">
-            <a:avLst/>
-          </a:prstGeom>
-          <a:noFill/>
-          <a:ln/>
-        </p:spPr>
-        <p:txBody>
-          <a:bodyPr wrap="square" lIns="0" tIns="0" rIns="0" bIns="0" rtlCol="0" anchor="ctr"/>
-          <a:lstStyle/>
-          <a:p>
-            <a:pPr indent="0" marL="0">
-              <a:buNone/>
-            </a:pPr>
-            <a:r>
-              <a:rPr lang="en-US" sz="1600" b="1" dirty="0">
-                <a:solidFill>
-                  <a:srgbClr val="ECEFF4"/>
-                </a:solidFill>
-                <a:latin typeface="Calibri" pitchFamily="34" charset="0"/>
-                <a:ea typeface="Calibri" pitchFamily="34" charset="-122"/>
-                <a:cs typeface="Calibri" pitchFamily="34" charset="-120"/>
-              </a:rPr>
-              <a:t>iPad mini 1</a:t>
-            </a:r>
-            <a:endParaRPr lang="en-US" sz="1600" dirty="0"/>
-          </a:p>
-        </p:txBody>
-      </p:sp>
-      <p:sp>
-        <p:nvSpPr>
-          <p:cNvPr id="9" name="Text 6"/>
-          <p:cNvSpPr/>
-          <p:nvPr/>
-        </p:nvSpPr>
-        <p:spPr>
-          <a:xfrm>
-            <a:off x="5989320" y="2651760"/>
-            <a:ext cx="2468880" cy="1554480"/>
-          </a:xfrm>
-          <a:prstGeom prst="rect">
-            <a:avLst/>
-          </a:prstGeom>
-          <a:noFill/>
-          <a:ln/>
-        </p:spPr>
-        <p:txBody>
-          <a:bodyPr wrap="square" lIns="0" tIns="0" rIns="0" bIns="0" rtlCol="0" anchor="t"/>
-          <a:lstStyle/>
-          <a:p>
-            <a:pPr indent="0" marL="0">
-              <a:lnSpc>
-                <a:spcPct val="105000"/>
-              </a:lnSpc>
-              <a:buNone/>
-            </a:pPr>
-            <a:r>
-              <a:rPr lang="en-US" sz="1350" dirty="0">
-                <a:solidFill>
-                  <a:srgbClr val="9AA6B5"/>
-                </a:solidFill>
-                <a:latin typeface="Calibri" pitchFamily="34" charset="0"/>
-                <a:ea typeface="Calibri" pitchFamily="34" charset="-122"/>
-                <a:cs typeface="Calibri" pitchFamily="34" charset="-120"/>
-              </a:rPr>
-              <a:t>2012 hardware, iOS 9, 32-bit armv7 — running a modern Tk app in 2026.</a:t>
-            </a:r>
-            <a:endParaRPr lang="en-US" sz="1350" dirty="0"/>
-          </a:p>
-        </p:txBody>
-      </p:sp>
-      <p:sp>
-        <p:nvSpPr>
-          <p:cNvPr id="10" name="Text 7"/>
           <p:cNvSpPr/>
           <p:nvPr/>
         </p:nvSpPr>
@@ -16196,7 +17379,7 @@
       </p:sp>
       <p:sp>
         <p:nvSpPr>
-          <p:cNvPr id="11" name="Text 8"/>
+          <p:cNvPr id="9" name="Text 6"/>
           <p:cNvSpPr/>
           <p:nvPr/>
         </p:nvSpPr>

</xml_diff>